<commit_message>
Updated template-driven investment deck engine
</commit_message>
<xml_diff>
--- a/template.pptx
+++ b/template.pptx
@@ -2136,7 +2136,7 @@
                 <a:ea typeface="Georgia" pitchFamily="34" charset="-122"/>
                 <a:cs typeface="Georgia" pitchFamily="34" charset="-120"/>
               </a:rPr>
-              <a:t>UGRO Capital Ltd.</a:t>
+              <a:t>{{COMPANY_NAME}}</a:t>
             </a:r>
             <a:endParaRPr lang="en-US" sz="4800" dirty="0"/>
           </a:p>
@@ -2200,7 +2200,7 @@
                 <a:ea typeface="Calibri" pitchFamily="34" charset="-122"/>
                 <a:cs typeface="Calibri" pitchFamily="34" charset="-120"/>
               </a:rPr>
-              <a:t>India's Premier DataTech MSME Lender</a:t>
+              <a:t>{{COMPANY_TAGLINE}}</a:t>
             </a:r>
             <a:endParaRPr lang="en-US" sz="1800" dirty="0"/>
           </a:p>
@@ -2236,7 +2236,7 @@
                   <a:srgbClr val="8899AA"/>
                 </a:solidFill>
               </a:rPr>
-              <a:t>Equity Story &amp; Strategic Overview</a:t>
+              <a:t>{{PRESENTATION_TITLE}}</a:t>
             </a:r>
             <a:endParaRPr lang="en-US" sz="1500" dirty="0"/>
           </a:p>
@@ -2300,7 +2300,7 @@
                 <a:ea typeface="Georgia" pitchFamily="34" charset="-122"/>
                 <a:cs typeface="Georgia" pitchFamily="34" charset="-120"/>
               </a:rPr>
-              <a:t>₹12,003 Cr</a:t>
+              <a:t>{{STAT1_VALUE}}</a:t>
             </a:r>
             <a:endParaRPr lang="en-US" sz="2200" dirty="0"/>
           </a:p>
@@ -2336,7 +2336,7 @@
                   <a:srgbClr val="8899AA"/>
                 </a:solidFill>
               </a:rPr>
-              <a:t>AUM (FY25)</a:t>
+              <a:t>{{STAT1_LABEL}}</a:t>
             </a:r>
             <a:endParaRPr lang="en-US" sz="1000" dirty="0"/>
           </a:p>
@@ -2400,7 +2400,7 @@
                 <a:ea typeface="Georgia" pitchFamily="34" charset="-122"/>
                 <a:cs typeface="Georgia" pitchFamily="34" charset="-120"/>
               </a:rPr>
-              <a:t>33%</a:t>
+              <a:t>{{STAT2_VALUE}}</a:t>
             </a:r>
             <a:endParaRPr lang="en-US" sz="2200" dirty="0"/>
           </a:p>
@@ -2436,7 +2436,7 @@
                   <a:srgbClr val="8899AA"/>
                 </a:solidFill>
               </a:rPr>
-              <a:t>YoY AUM Growth</a:t>
+              <a:t>{{STAT2_LABEL}}</a:t>
             </a:r>
             <a:endParaRPr lang="en-US" sz="1000" dirty="0"/>
           </a:p>
@@ -2500,7 +2500,7 @@
                 <a:ea typeface="Georgia" pitchFamily="34" charset="-122"/>
                 <a:cs typeface="Georgia" pitchFamily="34" charset="-120"/>
               </a:rPr>
-              <a:t>2.3%</a:t>
+              <a:t>{{STAT3_VALUE}}</a:t>
             </a:r>
             <a:endParaRPr lang="en-US" sz="2200" dirty="0"/>
           </a:p>
@@ -2536,7 +2536,7 @@
                   <a:srgbClr val="8899AA"/>
                 </a:solidFill>
               </a:rPr>
-              <a:t>GNPA</a:t>
+              <a:t>{{STAT3_LABEL}}</a:t>
             </a:r>
             <a:endParaRPr lang="en-US" sz="1000" dirty="0"/>
           </a:p>
@@ -2600,7 +2600,7 @@
                 <a:ea typeface="Georgia" pitchFamily="34" charset="-122"/>
                 <a:cs typeface="Georgia" pitchFamily="34" charset="-120"/>
               </a:rPr>
-              <a:t>₹1,265 Cr</a:t>
+              <a:t>{{STAT4_VALUE}}</a:t>
             </a:r>
             <a:endParaRPr lang="en-US" sz="2200" dirty="0"/>
           </a:p>
@@ -2636,7 +2636,7 @@
                   <a:srgbClr val="8899AA"/>
                 </a:solidFill>
               </a:rPr>
-              <a:t>Equity Raised (FY25)</a:t>
+              <a:t>{{STAT4_LABEL}}</a:t>
             </a:r>
             <a:endParaRPr lang="en-US" sz="1000" dirty="0"/>
           </a:p>
@@ -2672,7 +2672,7 @@
                   <a:srgbClr val="8899AA"/>
                 </a:solidFill>
               </a:rPr>
-              <a:t>Prepared by: Investment Banking Division  |  May 2025  |  For Discussion Purposes Only</a:t>
+              <a:t>Prepared by: {{IB_DIVISION_NAME}}  |  {{PRESENTATION_DATE}}  |  For Discussion Purposes Only</a:t>
             </a:r>
             <a:endParaRPr lang="en-US" sz="750" dirty="0"/>
           </a:p>
@@ -2768,7 +2768,7 @@
                 <a:ea typeface="Georgia" pitchFamily="34" charset="-122"/>
                 <a:cs typeface="Georgia" pitchFamily="34" charset="-120"/>
               </a:rPr>
-              <a:t>08  |  VALUATION CONSIDERATIONS</a:t>
+              <a:t>{{SECTION_08_HEADER}}</a:t>
             </a:r>
             <a:endParaRPr lang="en-US" sz="1800" dirty="0"/>
           </a:p>
@@ -2854,7 +2854,7 @@
                   <a:srgbClr val="E8C96B"/>
                 </a:solidFill>
               </a:rPr>
-              <a:t>Key Valuation Metrics</a:t>
+              <a:t>{{S08_LEFT_TITLE}}</a:t>
             </a:r>
             <a:endParaRPr lang="en-US" sz="1200" dirty="0"/>
           </a:p>
@@ -2890,7 +2890,7 @@
                   <a:srgbClr val="8899AA"/>
                 </a:solidFill>
               </a:rPr>
-              <a:t>Book Value / Share (Mar'25)</a:t>
+              <a:t>{{S08_METRIC1_LABEL}}</a:t>
             </a:r>
             <a:endParaRPr lang="en-US" sz="950" dirty="0"/>
           </a:p>
@@ -2926,7 +2926,7 @@
                   <a:srgbClr val="E8C96B"/>
                 </a:solidFill>
               </a:rPr>
-              <a:t>₹219.6</a:t>
+              <a:t>{{S08_METRIC1_VALUE}}</a:t>
             </a:r>
             <a:endParaRPr lang="en-US" sz="1100" dirty="0"/>
           </a:p>
@@ -2962,7 +2962,7 @@
                   <a:srgbClr val="8899AA"/>
                 </a:solidFill>
               </a:rPr>
-              <a:t>EPS (FY25)</a:t>
+              <a:t>{{S08_METRIC2_LABEL}}</a:t>
             </a:r>
             <a:endParaRPr lang="en-US" sz="950" dirty="0"/>
           </a:p>
@@ -2998,7 +2998,7 @@
                   <a:srgbClr val="E8C96B"/>
                 </a:solidFill>
               </a:rPr>
-              <a:t>₹15.68</a:t>
+              <a:t>{{S08_METRIC2_VALUE}}</a:t>
             </a:r>
             <a:endParaRPr lang="en-US" sz="1100" dirty="0"/>
           </a:p>
@@ -3034,7 +3034,7 @@
                   <a:srgbClr val="8899AA"/>
                 </a:solidFill>
               </a:rPr>
-              <a:t>ROE (FY25)¹</a:t>
+              <a:t>{{S08_METRIC3_LABEL}}</a:t>
             </a:r>
             <a:endParaRPr lang="en-US" sz="950" dirty="0"/>
           </a:p>
@@ -3070,7 +3070,7 @@
                   <a:srgbClr val="E8C96B"/>
                 </a:solidFill>
               </a:rPr>
-              <a:t>9.9%</a:t>
+              <a:t>{{S08_METRIC3_VALUE}}</a:t>
             </a:r>
             <a:endParaRPr lang="en-US" sz="1100" dirty="0"/>
           </a:p>
@@ -3106,7 +3106,7 @@
                   <a:srgbClr val="8899AA"/>
                 </a:solidFill>
               </a:rPr>
-              <a:t>ROA (FY25)</a:t>
+              <a:t>{{S08_METRIC4_LABEL}}</a:t>
             </a:r>
             <a:endParaRPr lang="en-US" sz="950" dirty="0"/>
           </a:p>
@@ -3142,7 +3142,7 @@
                   <a:srgbClr val="E8C96B"/>
                 </a:solidFill>
               </a:rPr>
-              <a:t>2.8%</a:t>
+              <a:t>{{S08_METRIC4_VALUE}}</a:t>
             </a:r>
             <a:endParaRPr lang="en-US" sz="1100" dirty="0"/>
           </a:p>
@@ -3178,7 +3178,7 @@
                   <a:srgbClr val="8899AA"/>
                 </a:solidFill>
               </a:rPr>
-              <a:t>Net Worth</a:t>
+              <a:t>{{S08_METRIC5_LABEL}}</a:t>
             </a:r>
             <a:endParaRPr lang="en-US" sz="950" dirty="0"/>
           </a:p>
@@ -3214,7 +3214,7 @@
                   <a:srgbClr val="E8C96B"/>
                 </a:solidFill>
               </a:rPr>
-              <a:t>~₹2,000 Cr</a:t>
+              <a:t>{{S08_METRIC5_VALUE}}</a:t>
             </a:r>
             <a:endParaRPr lang="en-US" sz="1100" dirty="0"/>
           </a:p>
@@ -3250,7 +3250,7 @@
                   <a:srgbClr val="8899AA"/>
                 </a:solidFill>
               </a:rPr>
-              <a:t>CRAR</a:t>
+              <a:t>{{S08_METRIC6_LABEL}}</a:t>
             </a:r>
             <a:endParaRPr lang="en-US" sz="950" dirty="0"/>
           </a:p>
@@ -3286,7 +3286,7 @@
                   <a:srgbClr val="E8C96B"/>
                 </a:solidFill>
               </a:rPr>
-              <a:t>20.8%</a:t>
+              <a:t>{{S08_METRIC6_VALUE}}</a:t>
             </a:r>
             <a:endParaRPr lang="en-US" sz="1100" dirty="0"/>
           </a:p>
@@ -3347,7 +3347,7 @@
                   <a:srgbClr val="0A1628"/>
                 </a:solidFill>
               </a:rPr>
-              <a:t>MSME NBFC Peer Benchmarking</a:t>
+              <a:t>{{S08_TABLE_TITLE}}</a:t>
             </a:r>
             <a:endParaRPr lang="en-US" sz="1200" dirty="0"/>
           </a:p>
@@ -3704,7 +3704,7 @@
                             <a:srgbClr val="0E7C7B"/>
                           </a:solidFill>
                         </a:rPr>
-                        <a:t>UGRO Capital</a:t>
+                        <a:t>{{S08_PEER0_NAME}}</a:t>
                       </a:r>
                       <a:endParaRPr lang="en-US" sz="950" dirty="0"/>
                     </a:p>
@@ -3765,7 +3765,7 @@
                             <a:srgbClr val="0E7C7B"/>
                           </a:solidFill>
                         </a:rPr>
-                        <a:t>33%</a:t>
+                        <a:t>{{S08_PEER0_AUM_GR}}</a:t>
                       </a:r>
                       <a:endParaRPr lang="en-US" sz="950" dirty="0"/>
                     </a:p>
@@ -3826,7 +3826,7 @@
                             <a:srgbClr val="0E7C7B"/>
                           </a:solidFill>
                         </a:rPr>
-                        <a:t>2.3%</a:t>
+                        <a:t>{{S08_PEER0_GNPA}}</a:t>
                       </a:r>
                       <a:endParaRPr lang="en-US" sz="950" dirty="0"/>
                     </a:p>
@@ -3887,7 +3887,7 @@
                             <a:srgbClr val="0E7C7B"/>
                           </a:solidFill>
                         </a:rPr>
-                        <a:t>2.8%</a:t>
+                        <a:t>{{S08_PEER0_ROA}}</a:t>
                       </a:r>
                       <a:endParaRPr lang="en-US" sz="950" dirty="0"/>
                     </a:p>
@@ -3948,7 +3948,7 @@
                             <a:srgbClr val="0E7C7B"/>
                           </a:solidFill>
                         </a:rPr>
-                        <a:t>DataTech MSME</a:t>
+                        <a:t>{{S08_PEER0_POS}}</a:t>
                       </a:r>
                       <a:endParaRPr lang="en-US" sz="950" dirty="0"/>
                     </a:p>
@@ -4011,7 +4011,7 @@
                             <a:srgbClr val="0A1628"/>
                           </a:solidFill>
                         </a:rPr>
-                        <a:t>Five Star BF</a:t>
+                        <a:t>{{S08_PEER1_NAME}}</a:t>
                       </a:r>
                       <a:endParaRPr lang="en-US" sz="950" dirty="0"/>
                     </a:p>
@@ -4072,7 +4072,7 @@
                             <a:srgbClr val="0A1628"/>
                           </a:solidFill>
                         </a:rPr>
-                        <a:t>26%</a:t>
+                        <a:t>{{S08_PEER1_AUM_GR}}</a:t>
                       </a:r>
                       <a:endParaRPr lang="en-US" sz="950" dirty="0"/>
                     </a:p>
@@ -4133,7 +4133,7 @@
                             <a:srgbClr val="0A1628"/>
                           </a:solidFill>
                         </a:rPr>
-                        <a:t>1.4%</a:t>
+                        <a:t>{{S08_PEER1_GNPA}}</a:t>
                       </a:r>
                       <a:endParaRPr lang="en-US" sz="950" dirty="0"/>
                     </a:p>
@@ -4194,7 +4194,7 @@
                             <a:srgbClr val="0A1628"/>
                           </a:solidFill>
                         </a:rPr>
-                        <a:t>6.0%</a:t>
+                        <a:t>{{S08_PEER1_ROA}}</a:t>
                       </a:r>
                       <a:endParaRPr lang="en-US" sz="950" dirty="0"/>
                     </a:p>
@@ -4255,7 +4255,7 @@
                             <a:srgbClr val="0A1628"/>
                           </a:solidFill>
                         </a:rPr>
-                        <a:t>Secured SME</a:t>
+                        <a:t>{{S08_PEER1_POS}}</a:t>
                       </a:r>
                       <a:endParaRPr lang="en-US" sz="950" dirty="0"/>
                     </a:p>
@@ -4318,7 +4318,7 @@
                             <a:srgbClr val="0A1628"/>
                           </a:solidFill>
                         </a:rPr>
-                        <a:t>Capri Global</a:t>
+                        <a:t>{{S08_PEER2_NAME}}</a:t>
                       </a:r>
                       <a:endParaRPr lang="en-US" sz="950" dirty="0"/>
                     </a:p>
@@ -4379,7 +4379,7 @@
                             <a:srgbClr val="0A1628"/>
                           </a:solidFill>
                         </a:rPr>
-                        <a:t>30%</a:t>
+                        <a:t>{{S08_PEER2_AUM_GR}}</a:t>
                       </a:r>
                       <a:endParaRPr lang="en-US" sz="950" dirty="0"/>
                     </a:p>
@@ -4440,7 +4440,7 @@
                             <a:srgbClr val="0A1628"/>
                           </a:solidFill>
                         </a:rPr>
-                        <a:t>2.1%</a:t>
+                        <a:t>{{S08_PEER2_GNPA}}</a:t>
                       </a:r>
                       <a:endParaRPr lang="en-US" sz="950" dirty="0"/>
                     </a:p>
@@ -4501,7 +4501,7 @@
                             <a:srgbClr val="0A1628"/>
                           </a:solidFill>
                         </a:rPr>
-                        <a:t>2.5%</a:t>
+                        <a:t>{{S08_PEER2_ROA}}</a:t>
                       </a:r>
                       <a:endParaRPr lang="en-US" sz="950" dirty="0"/>
                     </a:p>
@@ -4562,7 +4562,7 @@
                             <a:srgbClr val="0A1628"/>
                           </a:solidFill>
                         </a:rPr>
-                        <a:t>MSME Mixed</a:t>
+                        <a:t>{{S08_PEER2_POS}}</a:t>
                       </a:r>
                       <a:endParaRPr lang="en-US" sz="950" dirty="0"/>
                     </a:p>
@@ -4625,7 +4625,7 @@
                             <a:srgbClr val="0A1628"/>
                           </a:solidFill>
                         </a:rPr>
-                        <a:t>U GRO Peers avg</a:t>
+                        <a:t>{{S08_PEER3_NAME}}</a:t>
                       </a:r>
                       <a:endParaRPr lang="en-US" sz="950" dirty="0"/>
                     </a:p>
@@ -4686,7 +4686,7 @@
                             <a:srgbClr val="0A1628"/>
                           </a:solidFill>
                         </a:rPr>
-                        <a:t>~25%</a:t>
+                        <a:t>{{S08_PEER3_AUM_GR}}</a:t>
                       </a:r>
                       <a:endParaRPr lang="en-US" sz="950" dirty="0"/>
                     </a:p>
@@ -4747,7 +4747,7 @@
                             <a:srgbClr val="0A1628"/>
                           </a:solidFill>
                         </a:rPr>
-                        <a:t>~2.0%</a:t>
+                        <a:t>{{S08_PEER3_GNPA}}</a:t>
                       </a:r>
                       <a:endParaRPr lang="en-US" sz="950" dirty="0"/>
                     </a:p>
@@ -4808,7 +4808,7 @@
                             <a:srgbClr val="0A1628"/>
                           </a:solidFill>
                         </a:rPr>
-                        <a:t>~3.0%</a:t>
+                        <a:t>{{S08_PEER3_ROA}}</a:t>
                       </a:r>
                       <a:endParaRPr lang="en-US" sz="950" dirty="0"/>
                     </a:p>
@@ -4869,7 +4869,7 @@
                             <a:srgbClr val="0A1628"/>
                           </a:solidFill>
                         </a:rPr>
-                        <a:t>MSME-focused</a:t>
+                        <a:t>{{S08_PEER3_POS}}</a:t>
                       </a:r>
                       <a:endParaRPr lang="en-US" sz="950" dirty="0"/>
                     </a:p>
@@ -5004,7 +5004,7 @@
                 <a:ea typeface="Georgia" pitchFamily="34" charset="-122"/>
                 <a:cs typeface="Georgia" pitchFamily="34" charset="-120"/>
               </a:rPr>
-              <a:t>Investment Summary</a:t>
+              <a:t>{{S08_SUMMARY_TITLE}}</a:t>
             </a:r>
             <a:endParaRPr lang="en-US" sz="1300" dirty="0"/>
           </a:p>
@@ -5044,7 +5044,7 @@
                   <a:srgbClr val="D0DCF0"/>
                 </a:solidFill>
               </a:rPr>
-              <a:t>UGRO Capital is a structurally differentiated MSME lender — patented technology, proven execution, and India's largest addressable credit gap as the secular tailwind.</a:t>
+              <a:t>{{S08_PEER0_NAME}} is a structurally differentiated MSME lender — patented technology, proven execution, and India's largest addressable credit gap as the secular tailwind.</a:t>
             </a:r>
             <a:endParaRPr lang="en-US" sz="1000" dirty="0"/>
           </a:p>
@@ -5062,7 +5062,7 @@
                   <a:srgbClr val="D0DCF0"/>
                 </a:solidFill>
               </a:rPr>
-              <a:t>FY25 marked an inflection: ₹12,000 Cr AUM, ₹1,265 Cr equity raise, IND A+ ratings, and highest-ever quarterly disbursements — all while maintaining GNPA discipline.</a:t>
+              <a:t>{{S08_SUMMARY_BULLET2}}</a:t>
             </a:r>
             <a:endParaRPr lang="en-US" sz="1000" dirty="0"/>
           </a:p>
@@ -5080,7 +5080,7 @@
                   <a:srgbClr val="D0DCF0"/>
                 </a:solidFill>
               </a:rPr>
-              <a:t>At ~1x P/BV on FY25 book of ₹219.6/share, the stock offers a compelling entry into a compounding ROE story as operating leverage, yield mix improvement, and co-lending economics converge in FY26–27.</a:t>
+              <a:t>{{S08_SUMMARY_BULLET3}}</a:t>
             </a:r>
             <a:endParaRPr lang="en-US" sz="1000" dirty="0"/>
           </a:p>
@@ -5116,7 +5116,7 @@
                   <a:srgbClr val="8899AA"/>
                 </a:solidFill>
               </a:rPr>
-              <a:t>¹ Excluding equity component of CCDs</a:t>
+              <a:t>{{S08_FOOTNOTE}}</a:t>
             </a:r>
             <a:endParaRPr lang="en-US" sz="750" dirty="0"/>
           </a:p>
@@ -5241,7 +5241,7 @@
                 <a:ea typeface="Georgia" pitchFamily="34" charset="-122"/>
                 <a:cs typeface="Georgia" pitchFamily="34" charset="-120"/>
               </a:rPr>
-              <a:t>UGRO Capital Ltd.</a:t>
+              <a:t>{{COMPANY_NAME}}</a:t>
             </a:r>
             <a:endParaRPr lang="en-US" sz="4200" dirty="0"/>
           </a:p>
@@ -5277,7 +5277,7 @@
                   <a:srgbClr val="E8C96B"/>
                 </a:solidFill>
               </a:rPr>
-              <a:t>MSME Accha Hai! — Expanding Horizons</a:t>
+              <a:t>{{COMPANY_TAGLINE_CLOSING}}</a:t>
             </a:r>
             <a:endParaRPr lang="en-US" sz="1800" dirty="0"/>
           </a:p>
@@ -5374,7 +5374,7 @@
                   <a:srgbClr val="FFFFFF"/>
                 </a:solidFill>
               </a:rPr>
-              <a:t>Investment Banking Division</a:t>
+              <a:t>{{IB_DIVISION_NAME}}</a:t>
             </a:r>
             <a:endParaRPr lang="en-US" sz="1400" dirty="0"/>
           </a:p>
@@ -5475,7 +5475,7 @@
                   <a:srgbClr val="8899AA"/>
                 </a:solidFill>
               </a:rPr>
-              <a:t>This presentation has been prepared by the Investment Banking Division for discussion purposes only and does not constitute an offer to sell or solicitation to buy any securities. The information contained herein is derived from UGRO Capital's Annual Report FY2024-25 and publicly available sources. Past performance is not indicative of future results. Potential investors should conduct their own due diligence and seek independent professional advice. This document is strictly confidential and intended solely for the designated recipient.</a:t>
+              <a:t>This presentation has been prepared by the {{IB_DIVISION_NAME}} for discussion purposes only and does not constitute an offer to sell or solicitation to buy any securities. The information contained herein is derived from {{COMPANY_NAME}}'s Annual Report {{REPORT_YEAR}} and publicly available sources. Past performance is not indicative of future results. Potential investors should conduct their own due diligence and seek independent professional advice. This document is strictly confidential and intended solely for the designated recipient.</a:t>
             </a:r>
             <a:endParaRPr lang="en-US" sz="800" dirty="0"/>
           </a:p>
@@ -5721,7 +5721,7 @@
                   <a:srgbClr val="0A1628"/>
                 </a:solidFill>
               </a:rPr>
-              <a:t>Investment Thesis</a:t>
+              <a:t>{{CLIENT_SITUATIONAL_ANALYSIS}}</a:t>
             </a:r>
             <a:endParaRPr lang="en-US" sz="1200" dirty="0"/>
           </a:p>
@@ -5757,7 +5757,7 @@
                   <a:srgbClr val="8899AA"/>
                 </a:solidFill>
               </a:rPr>
-              <a:t>Why UGRO Capital is a Compelling Opportunity</a:t>
+              <a:t>{{CLIENT_SITUATIONAL_ANALYSIS_SUBTITLE}}</a:t>
             </a:r>
             <a:endParaRPr lang="en-US" sz="900" dirty="0"/>
           </a:p>
@@ -5882,7 +5882,7 @@
                   <a:srgbClr val="0A1628"/>
                 </a:solidFill>
               </a:rPr>
-              <a:t>Company Overview &amp; Business Model</a:t>
+              <a:t>{{SWOT_ANALYSIS}}</a:t>
             </a:r>
             <a:endParaRPr lang="en-US" sz="1200" dirty="0"/>
           </a:p>
@@ -5918,7 +5918,7 @@
                   <a:srgbClr val="8899AA"/>
                 </a:solidFill>
               </a:rPr>
-              <a:t>DataTech-Led MSME Lending Platform</a:t>
+              <a:t>{{SWOT_ANALYSIS_SUBTITLE}}</a:t>
             </a:r>
             <a:endParaRPr lang="en-US" sz="900" dirty="0"/>
           </a:p>
@@ -6043,7 +6043,7 @@
                   <a:srgbClr val="0A1628"/>
                 </a:solidFill>
               </a:rPr>
-              <a:t>Financial Performance</a:t>
+              <a:t>{{FINANCIAL_PERFORMANCE_OVERVIEW}}</a:t>
             </a:r>
             <a:endParaRPr lang="en-US" sz="1200" dirty="0"/>
           </a:p>
@@ -6079,7 +6079,7 @@
                   <a:srgbClr val="8899AA"/>
                 </a:solidFill>
               </a:rPr>
-              <a:t>Strong Growth with Improving Unit Economics</a:t>
+              <a:t>{{FINANCIAL_PERFORMANCE_OVERVIEW_SUBTITLE}}</a:t>
             </a:r>
             <a:endParaRPr lang="en-US" sz="900" dirty="0"/>
           </a:p>
@@ -6204,7 +6204,7 @@
                   <a:srgbClr val="0A1628"/>
                 </a:solidFill>
               </a:rPr>
-              <a:t>Competitive Positioning &amp; Moat</a:t>
+              <a:t>{{COMPETITIVE_POSITION}}</a:t>
             </a:r>
             <a:endParaRPr lang="en-US" sz="1200" dirty="0"/>
           </a:p>
@@ -6240,7 +6240,7 @@
                   <a:srgbClr val="8899AA"/>
                 </a:solidFill>
               </a:rPr>
-              <a:t>GRO Score™ &amp; Multi-Channel Distribution</a:t>
+              <a:t>{{COMPETITIVE_POSITION_SUBTITLE}}</a:t>
             </a:r>
             <a:endParaRPr lang="en-US" sz="900" dirty="0"/>
           </a:p>
@@ -6365,7 +6365,7 @@
                   <a:srgbClr val="0A1628"/>
                 </a:solidFill>
               </a:rPr>
-              <a:t>Market Opportunity</a:t>
+              <a:t>{{MARKET_INDUSTRY_OVERVIEW}}</a:t>
             </a:r>
             <a:endParaRPr lang="en-US" sz="1200" dirty="0"/>
           </a:p>
@@ -6401,7 +6401,7 @@
                   <a:srgbClr val="8899AA"/>
                 </a:solidFill>
               </a:rPr>
-              <a:t>₹103 Trillion MSME Credit Gap</a:t>
+              <a:t>{{MARKET_INDUSTRY_OVERVIEW_SUBTITLE}}</a:t>
             </a:r>
             <a:endParaRPr lang="en-US" sz="900" dirty="0"/>
           </a:p>
@@ -6526,7 +6526,7 @@
                   <a:srgbClr val="0A1628"/>
                 </a:solidFill>
               </a:rPr>
-              <a:t>Risk Factors</a:t>
+              <a:t>{{KEY_CONSIDERATIONS_RISK_FACTORS}}</a:t>
             </a:r>
             <a:endParaRPr lang="en-US" sz="1200" dirty="0"/>
           </a:p>
@@ -6562,7 +6562,7 @@
                   <a:srgbClr val="8899AA"/>
                 </a:solidFill>
               </a:rPr>
-              <a:t>Key Risks and Mitigants</a:t>
+              <a:t>{{KEY_CONSIDERATIONS_RISK_FACTORS_SUBTITLE}}</a:t>
             </a:r>
             <a:endParaRPr lang="en-US" sz="900" dirty="0"/>
           </a:p>
@@ -6687,7 +6687,7 @@
                   <a:srgbClr val="0A1628"/>
                 </a:solidFill>
               </a:rPr>
-              <a:t>FY26 Strategy &amp; Outlook</a:t>
+              <a:t>{{STRATEGIC_OPTIONS_THESIS}}</a:t>
             </a:r>
             <a:endParaRPr lang="en-US" sz="1200" dirty="0"/>
           </a:p>
@@ -6723,7 +6723,7 @@
                   <a:srgbClr val="8899AA"/>
                 </a:solidFill>
               </a:rPr>
-              <a:t>Roadmap to ₹16,000–17,000 Cr AUM</a:t>
+              <a:t>{{STRATEGIC_OPTIONS_THESIS_SUBTITLE}}</a:t>
             </a:r>
             <a:endParaRPr lang="en-US" sz="900" dirty="0"/>
           </a:p>
@@ -6848,7 +6848,7 @@
                   <a:srgbClr val="0A1628"/>
                 </a:solidFill>
               </a:rPr>
-              <a:t>Valuation Considerations</a:t>
+              <a:t>{{VALUATION_ANALYSIS}}</a:t>
             </a:r>
             <a:endParaRPr lang="en-US" sz="1200" dirty="0"/>
           </a:p>
@@ -6884,7 +6884,7 @@
                   <a:srgbClr val="8899AA"/>
                 </a:solidFill>
               </a:rPr>
-              <a:t>Peer Benchmarking &amp; Investment Returns</a:t>
+              <a:t>{{VALUATION_ANALYSIS_SUBTITLE}}</a:t>
             </a:r>
             <a:endParaRPr lang="en-US" sz="900" dirty="0"/>
           </a:p>
@@ -6980,7 +6980,7 @@
                 <a:ea typeface="Georgia" pitchFamily="34" charset="-122"/>
                 <a:cs typeface="Georgia" pitchFamily="34" charset="-120"/>
               </a:rPr>
-              <a:t>01  |  INVESTMENT THESIS</a:t>
+              <a:t>{{SECTION_01_HEADER}}</a:t>
             </a:r>
             <a:endParaRPr lang="en-US" sz="1800" dirty="0"/>
           </a:p>
@@ -7041,7 +7041,7 @@
                   <a:srgbClr val="1A3567"/>
                 </a:solidFill>
               </a:rPr>
-              <a:t>Six Reasons to Own UGRO Capital</a:t>
+              <a:t>{{SECTION_01_TITLE}}</a:t>
             </a:r>
             <a:endParaRPr lang="en-US" sz="1300" dirty="0"/>
           </a:p>
@@ -7081,7 +7081,7 @@
       </p:sp>
       <p:pic>
         <p:nvPicPr>
-          <p:cNvPr id="7" name="Image 0" descr="preencoded.png">    </p:cNvPr>
+          <p:cNvPr id="7" name="Image 0" descr="preencoded.png"/>
           <p:cNvPicPr>
             <a:picLocks noChangeAspect="1"/>
           </p:cNvPicPr>
@@ -7133,7 +7133,7 @@
                   <a:srgbClr val="0A1628"/>
                 </a:solidFill>
               </a:rPr>
-              <a:t>Structural Tailwind</a:t>
+              <a:t>{{S01_POINT1_TITLE}}</a:t>
             </a:r>
             <a:endParaRPr lang="en-US" sz="1100" dirty="0"/>
           </a:p>
@@ -7169,7 +7169,7 @@
                   <a:srgbClr val="1A3567"/>
                 </a:solidFill>
               </a:rPr>
-              <a:t>₹103 trillion MSME credit gap; only 25M of 63M MSMEs access formal credit. India's largest under-penetrated lending opportunity.</a:t>
+              <a:t>{{S01_POINT1_BODY}}</a:t>
             </a:r>
             <a:endParaRPr lang="en-US" sz="950" dirty="0"/>
           </a:p>
@@ -7209,7 +7209,7 @@
       </p:sp>
       <p:pic>
         <p:nvPicPr>
-          <p:cNvPr id="11" name="Image 1" descr="preencoded.png">    </p:cNvPr>
+          <p:cNvPr id="11" name="Image 1" descr="preencoded.png"/>
           <p:cNvPicPr>
             <a:picLocks noChangeAspect="1"/>
           </p:cNvPicPr>
@@ -7261,7 +7261,7 @@
                   <a:srgbClr val="0A1628"/>
                 </a:solidFill>
               </a:rPr>
-              <a:t>Proprietary Tech Moat</a:t>
+              <a:t>{{S01_POINT2_TITLE}}</a:t>
             </a:r>
             <a:endParaRPr lang="en-US" sz="1100" dirty="0"/>
           </a:p>
@@ -7297,7 +7297,7 @@
                   <a:srgbClr val="1A3567"/>
                 </a:solidFill>
               </a:rPr>
-              <a:t>GRO Score™ — patented ML-driven credit engine ingesting 10,000+ data points. 1.7 lakh+ loans scored. Impossible to replicate overnight.</a:t>
+              <a:t>{{S01_POINT2_BODY}}</a:t>
             </a:r>
             <a:endParaRPr lang="en-US" sz="950" dirty="0"/>
           </a:p>
@@ -7337,7 +7337,7 @@
       </p:sp>
       <p:pic>
         <p:nvPicPr>
-          <p:cNvPr id="15" name="Image 2" descr="preencoded.png">    </p:cNvPr>
+          <p:cNvPr id="15" name="Image 2" descr="preencoded.png"/>
           <p:cNvPicPr>
             <a:picLocks noChangeAspect="1"/>
           </p:cNvPicPr>
@@ -7389,7 +7389,7 @@
                   <a:srgbClr val="0A1628"/>
                 </a:solidFill>
               </a:rPr>
-              <a:t>Accelerating Growth</a:t>
+              <a:t>{{S01_POINT3_TITLE}}</a:t>
             </a:r>
             <a:endParaRPr lang="en-US" sz="1100" dirty="0"/>
           </a:p>
@@ -7425,7 +7425,7 @@
                   <a:srgbClr val="1A3567"/>
                 </a:solidFill>
               </a:rPr>
-              <a:t>33% AUM CAGR to ₹12,003 Cr in FY25. Highest-ever quarterly disbursements of ₹2,436 Cr in Q4 FY25 (+57% YoY). Runway to ₹16,000–17,000 Cr by FY26.</a:t>
+              <a:t>{{S01_POINT3_BODY}}</a:t>
             </a:r>
             <a:endParaRPr lang="en-US" sz="950" dirty="0"/>
           </a:p>
@@ -7465,7 +7465,7 @@
       </p:sp>
       <p:pic>
         <p:nvPicPr>
-          <p:cNvPr id="19" name="Image 3" descr="preencoded.png">    </p:cNvPr>
+          <p:cNvPr id="19" name="Image 3" descr="preencoded.png"/>
           <p:cNvPicPr>
             <a:picLocks noChangeAspect="1"/>
           </p:cNvPicPr>
@@ -7517,7 +7517,7 @@
                   <a:srgbClr val="0A1628"/>
                 </a:solidFill>
               </a:rPr>
-              <a:t>Asset Quality Discipline</a:t>
+              <a:t>{{S01_POINT4_TITLE}}</a:t>
             </a:r>
             <a:endParaRPr lang="en-US" sz="1100" dirty="0"/>
           </a:p>
@@ -7553,7 +7553,7 @@
                   <a:srgbClr val="1A3567"/>
                 </a:solidFill>
               </a:rPr>
-              <a:t>GNPA of 2.3% and NNPA of 1.6% despite rapid scale-up. Secured portfolio with 3.7–4% credit costs, well within target range.</a:t>
+              <a:t>{{S01_POINT4_BODY}}</a:t>
             </a:r>
             <a:endParaRPr lang="en-US" sz="950" dirty="0"/>
           </a:p>
@@ -7593,7 +7593,7 @@
       </p:sp>
       <p:pic>
         <p:nvPicPr>
-          <p:cNvPr id="23" name="Image 4" descr="preencoded.png">    </p:cNvPr>
+          <p:cNvPr id="23" name="Image 4" descr="preencoded.png"/>
           <p:cNvPicPr>
             <a:picLocks noChangeAspect="1"/>
           </p:cNvPicPr>
@@ -7645,7 +7645,7 @@
                   <a:srgbClr val="0A1628"/>
                 </a:solidFill>
               </a:rPr>
-              <a:t>Capital Strength</a:t>
+              <a:t>{{S01_POINT5_TITLE}}</a:t>
             </a:r>
             <a:endParaRPr lang="en-US" sz="1100" dirty="0"/>
           </a:p>
@@ -7681,7 +7681,7 @@
                   <a:srgbClr val="1A3567"/>
                 </a:solidFill>
               </a:rPr>
-              <a:t>₹1,265 Cr equity raise in FY25. CRAR of 20.8%. Net worth ~₹2,000 Cr. IND A+ rating on ₹3,700 Cr+ debt facilities. 17 co-lending bank partners.</a:t>
+              <a:t>{{S01_POINT5_BODY}}</a:t>
             </a:r>
             <a:endParaRPr lang="en-US" sz="950" dirty="0"/>
           </a:p>
@@ -7721,7 +7721,7 @@
       </p:sp>
       <p:pic>
         <p:nvPicPr>
-          <p:cNvPr id="27" name="Image 5" descr="preencoded.png">    </p:cNvPr>
+          <p:cNvPr id="27" name="Image 5" descr="preencoded.png"/>
           <p:cNvPicPr>
             <a:picLocks noChangeAspect="1"/>
           </p:cNvPicPr>
@@ -7773,7 +7773,7 @@
                   <a:srgbClr val="0A1628"/>
                 </a:solidFill>
               </a:rPr>
-              <a:t>Scalable Platform</a:t>
+              <a:t>{{S01_POINT6_TITLE}}</a:t>
             </a:r>
             <a:endParaRPr lang="en-US" sz="1100" dirty="0"/>
           </a:p>
@@ -7809,7 +7809,7 @@
                   <a:srgbClr val="1A3567"/>
                 </a:solidFill>
               </a:rPr>
-              <a:t>135,000+ active borrowers. 2,149 employees. 201 emerging-market branches. MSL embedded finance subsidiary adds a digital flywheel.</a:t>
+              <a:t>{{S01_POINT6_BODY}}</a:t>
             </a:r>
             <a:endParaRPr lang="en-US" sz="950" dirty="0"/>
           </a:p>
@@ -7905,7 +7905,7 @@
                 <a:ea typeface="Georgia" pitchFamily="34" charset="-122"/>
                 <a:cs typeface="Georgia" pitchFamily="34" charset="-120"/>
               </a:rPr>
-              <a:t>02  |  COMPANY OVERVIEW</a:t>
+              <a:t>{{SECTION_02_HEADER}}</a:t>
             </a:r>
             <a:endParaRPr lang="en-US" sz="1800" dirty="0"/>
           </a:p>
@@ -7966,7 +7966,7 @@
                   <a:srgbClr val="0A1628"/>
                 </a:solidFill>
               </a:rPr>
-              <a:t>UGRO Capital at a Glance</a:t>
+              <a:t>{{SECTION_02_TITLE}}</a:t>
             </a:r>
             <a:endParaRPr lang="en-US" sz="1300" dirty="0"/>
           </a:p>
@@ -8006,7 +8006,7 @@
                   <a:srgbClr val="1A3567"/>
                 </a:solidFill>
               </a:rPr>
-              <a:t>Listed NBFC (NSE/BSE) focused exclusively on MSME lending — India's first 'DataTech Lender'</a:t>
+              <a:t>{{S02_BULLET1}}</a:t>
             </a:r>
             <a:endParaRPr lang="en-US" sz="1050" dirty="0"/>
           </a:p>
@@ -8024,7 +8024,7 @@
                   <a:srgbClr val="1A3567"/>
                 </a:solidFill>
               </a:rPr>
-              <a:t>Founded 2018 by Shachindra Nath (ex-Religare Capital). Backed by marquee institutional investors</a:t>
+              <a:t>{{S02_BULLET2}}</a:t>
             </a:r>
             <a:endParaRPr lang="en-US" sz="1050" dirty="0"/>
           </a:p>
@@ -8042,7 +8042,7 @@
                   <a:srgbClr val="1A3567"/>
                 </a:solidFill>
               </a:rPr>
-              <a:t>Multi-channel distribution: Branch-led (220 branches), Co-lending (17 bank partners, 44% off-book AUM), Embedded Finance (MSL subsidiary)</a:t>
+              <a:t>{{S02_BULLET3}}</a:t>
             </a:r>
             <a:endParaRPr lang="en-US" sz="1050" dirty="0"/>
           </a:p>
@@ -8060,7 +8060,7 @@
                   <a:srgbClr val="1A3567"/>
                 </a:solidFill>
               </a:rPr>
-              <a:t>GRO Score™: Patented AI/ML credit engine processing 10,000+ variables across GST, banking, bureau &amp; psychometric data</a:t>
+              <a:t>{{S02_BULLET4}}</a:t>
             </a:r>
             <a:endParaRPr lang="en-US" sz="1050" dirty="0"/>
           </a:p>
@@ -8078,7 +8078,7 @@
                   <a:srgbClr val="1A3567"/>
                 </a:solidFill>
               </a:rPr>
-              <a:t>Diversified product suite: LAP, Business Loans, Machinery Finance, Retailer Finance, Doctor Loans, EDI Loans, Green Asset Finance</a:t>
+              <a:t>{{S02_BULLET5}}</a:t>
             </a:r>
             <a:endParaRPr lang="en-US" sz="1050" dirty="0"/>
           </a:p>
@@ -8096,7 +8096,7 @@
                   <a:srgbClr val="1A3567"/>
                 </a:solidFill>
               </a:rPr>
-              <a:t>Avg ticket size ~₹16 lakh; Emerging-Market yields ~19%; Cost of funds well-managed through co-lending</a:t>
+              <a:t>{{S02_BULLET6}}</a:t>
             </a:r>
             <a:endParaRPr lang="en-US" sz="1050" dirty="0"/>
           </a:p>
@@ -8157,7 +8157,7 @@
                   <a:srgbClr val="0A1628"/>
                 </a:solidFill>
               </a:rPr>
-              <a:t>Revenue &amp; AUM Channel Mix</a:t>
+              <a:t>{{S02_CHART_TITLE}}</a:t>
             </a:r>
             <a:endParaRPr lang="en-US" sz="1100" dirty="0"/>
           </a:p>
@@ -8246,7 +8246,7 @@
                 <a:ea typeface="Georgia" pitchFamily="34" charset="-122"/>
                 <a:cs typeface="Georgia" pitchFamily="34" charset="-120"/>
               </a:rPr>
-              <a:t>44%</a:t>
+              <a:t>{{S02_CH1_PCT}}</a:t>
             </a:r>
             <a:endParaRPr lang="en-US" sz="2200" dirty="0"/>
           </a:p>
@@ -8282,7 +8282,7 @@
                   <a:srgbClr val="0A1628"/>
                 </a:solidFill>
               </a:rPr>
-              <a:t>Co-Lending / Off-Book</a:t>
+              <a:t>{{S02_CH1_NAME}}</a:t>
             </a:r>
             <a:endParaRPr lang="en-US" sz="1100" dirty="0"/>
           </a:p>
@@ -8318,7 +8318,7 @@
                   <a:srgbClr val="8899AA"/>
                 </a:solidFill>
               </a:rPr>
-              <a:t>17 bank partners | Priority Sector</a:t>
+              <a:t>{{S02_CH1_DESC}}</a:t>
             </a:r>
             <a:endParaRPr lang="en-US" sz="900" dirty="0"/>
           </a:p>
@@ -8407,7 +8407,7 @@
                 <a:ea typeface="Georgia" pitchFamily="34" charset="-122"/>
                 <a:cs typeface="Georgia" pitchFamily="34" charset="-120"/>
               </a:rPr>
-              <a:t>34%</a:t>
+              <a:t>{{S02_CH2_PCT}}</a:t>
             </a:r>
             <a:endParaRPr lang="en-US" sz="2200" dirty="0"/>
           </a:p>
@@ -8443,7 +8443,7 @@
                   <a:srgbClr val="0A1628"/>
                 </a:solidFill>
               </a:rPr>
-              <a:t>Branch-Led (On-Book)</a:t>
+              <a:t>{{S02_CH2_NAME}}</a:t>
             </a:r>
             <a:endParaRPr lang="en-US" sz="1100" dirty="0"/>
           </a:p>
@@ -8479,7 +8479,7 @@
                   <a:srgbClr val="8899AA"/>
                 </a:solidFill>
               </a:rPr>
-              <a:t>220 branches | Secured &amp; Unsecured</a:t>
+              <a:t>{{S02_CH2_DESC}}</a:t>
             </a:r>
             <a:endParaRPr lang="en-US" sz="900" dirty="0"/>
           </a:p>
@@ -8568,7 +8568,7 @@
                 <a:ea typeface="Georgia" pitchFamily="34" charset="-122"/>
                 <a:cs typeface="Georgia" pitchFamily="34" charset="-120"/>
               </a:rPr>
-              <a:t>7%</a:t>
+              <a:t>{{S02_CH3_PCT}}</a:t>
             </a:r>
             <a:endParaRPr lang="en-US" sz="2200" dirty="0"/>
           </a:p>
@@ -8604,7 +8604,7 @@
                   <a:srgbClr val="0A1628"/>
                 </a:solidFill>
               </a:rPr>
-              <a:t>Embedded Finance (MSL)</a:t>
+              <a:t>{{S02_CH3_NAME}}</a:t>
             </a:r>
             <a:endParaRPr lang="en-US" sz="1100" dirty="0"/>
           </a:p>
@@ -8640,7 +8640,7 @@
                   <a:srgbClr val="8899AA"/>
                 </a:solidFill>
               </a:rPr>
-              <a:t>₹743 Cr AUM | Digital first</a:t>
+              <a:t>{{S02_CH3_DESC}}</a:t>
             </a:r>
             <a:endParaRPr lang="en-US" sz="900" dirty="0"/>
           </a:p>
@@ -8729,7 +8729,7 @@
                 <a:ea typeface="Georgia" pitchFamily="34" charset="-122"/>
                 <a:cs typeface="Georgia" pitchFamily="34" charset="-120"/>
               </a:rPr>
-              <a:t>15%</a:t>
+              <a:t>{{S02_CH4_PCT}}</a:t>
             </a:r>
             <a:endParaRPr lang="en-US" sz="2200" dirty="0"/>
           </a:p>
@@ -8765,7 +8765,7 @@
                   <a:srgbClr val="0A1628"/>
                 </a:solidFill>
               </a:rPr>
-              <a:t>Emerging Markets</a:t>
+              <a:t>{{S02_CH4_NAME}}</a:t>
             </a:r>
             <a:endParaRPr lang="en-US" sz="1100" dirty="0"/>
           </a:p>
@@ -8801,7 +8801,7 @@
                   <a:srgbClr val="8899AA"/>
                 </a:solidFill>
               </a:rPr>
-              <a:t>201 EM branches | Tier 2-5 towns</a:t>
+              <a:t>{{S02_CH4_DESC}}</a:t>
             </a:r>
             <a:endParaRPr lang="en-US" sz="900" dirty="0"/>
           </a:p>
@@ -8897,7 +8897,7 @@
                 <a:ea typeface="Georgia" pitchFamily="34" charset="-122"/>
                 <a:cs typeface="Georgia" pitchFamily="34" charset="-120"/>
               </a:rPr>
-              <a:t>03  |  FINANCIAL PERFORMANCE</a:t>
+              <a:t>{{SECTION_03_HEADER}}</a:t>
             </a:r>
             <a:endParaRPr lang="en-US" sz="1800" dirty="0"/>
           </a:p>
@@ -8986,7 +8986,7 @@
                 <a:ea typeface="Georgia" pitchFamily="34" charset="-122"/>
                 <a:cs typeface="Georgia" pitchFamily="34" charset="-120"/>
               </a:rPr>
-              <a:t>₹12,003 Cr</a:t>
+              <a:t>{{S03_KPI1_VALUE}}</a:t>
             </a:r>
             <a:endParaRPr lang="en-US" sz="1700" dirty="0"/>
           </a:p>
@@ -9022,7 +9022,7 @@
                   <a:srgbClr val="FFFFFF"/>
                 </a:solidFill>
               </a:rPr>
-              <a:t>AUM</a:t>
+              <a:t>{{S03_KPI1_LABEL}}</a:t>
             </a:r>
             <a:endParaRPr lang="en-US" sz="900" dirty="0"/>
           </a:p>
@@ -9058,7 +9058,7 @@
                   <a:srgbClr val="14B8B7"/>
                 </a:solidFill>
               </a:rPr>
-              <a:t>+33% YoY</a:t>
+              <a:t>{{S03_KPI1_GROWTH}}</a:t>
             </a:r>
             <a:endParaRPr lang="en-US" sz="850" dirty="0"/>
           </a:p>
@@ -9122,7 +9122,7 @@
                 <a:ea typeface="Georgia" pitchFamily="34" charset="-122"/>
                 <a:cs typeface="Georgia" pitchFamily="34" charset="-120"/>
               </a:rPr>
-              <a:t>₹7,651 Cr</a:t>
+              <a:t>{{S03_KPI2_VALUE}}</a:t>
             </a:r>
             <a:endParaRPr lang="en-US" sz="1700" dirty="0"/>
           </a:p>
@@ -9158,7 +9158,7 @@
                   <a:srgbClr val="FFFFFF"/>
                 </a:solidFill>
               </a:rPr>
-              <a:t>Disbursements</a:t>
+              <a:t>{{S03_KPI2_LABEL}}</a:t>
             </a:r>
             <a:endParaRPr lang="en-US" sz="900" dirty="0"/>
           </a:p>
@@ -9194,7 +9194,7 @@
                   <a:srgbClr val="14B8B7"/>
                 </a:solidFill>
               </a:rPr>
-              <a:t>+30% YoY</a:t>
+              <a:t>{{S03_KPI2_GROWTH}}</a:t>
             </a:r>
             <a:endParaRPr lang="en-US" sz="850" dirty="0"/>
           </a:p>
@@ -9258,7 +9258,7 @@
                 <a:ea typeface="Georgia" pitchFamily="34" charset="-122"/>
                 <a:cs typeface="Georgia" pitchFamily="34" charset="-120"/>
               </a:rPr>
-              <a:t>₹1,442 Cr</a:t>
+              <a:t>{{S03_KPI3_VALUE}}</a:t>
             </a:r>
             <a:endParaRPr lang="en-US" sz="1700" dirty="0"/>
           </a:p>
@@ -9294,7 +9294,7 @@
                   <a:srgbClr val="FFFFFF"/>
                 </a:solidFill>
               </a:rPr>
-              <a:t>Total Income</a:t>
+              <a:t>{{S03_KPI3_LABEL}}</a:t>
             </a:r>
             <a:endParaRPr lang="en-US" sz="900" dirty="0"/>
           </a:p>
@@ -9330,7 +9330,7 @@
                   <a:srgbClr val="14B8B7"/>
                 </a:solidFill>
               </a:rPr>
-              <a:t>+33% YoY</a:t>
+              <a:t>{{S03_KPI3_GROWTH}}</a:t>
             </a:r>
             <a:endParaRPr lang="en-US" sz="850" dirty="0"/>
           </a:p>
@@ -9394,7 +9394,7 @@
                 <a:ea typeface="Georgia" pitchFamily="34" charset="-122"/>
                 <a:cs typeface="Georgia" pitchFamily="34" charset="-120"/>
               </a:rPr>
-              <a:t>₹203 Cr</a:t>
+              <a:t>{{S03_KPI4_VALUE}}</a:t>
             </a:r>
             <a:endParaRPr lang="en-US" sz="1700" dirty="0"/>
           </a:p>
@@ -9430,7 +9430,7 @@
                   <a:srgbClr val="FFFFFF"/>
                 </a:solidFill>
               </a:rPr>
-              <a:t>PBT</a:t>
+              <a:t>{{S03_KPI4_LABEL}}</a:t>
             </a:r>
             <a:endParaRPr lang="en-US" sz="900" dirty="0"/>
           </a:p>
@@ -9466,7 +9466,7 @@
                   <a:srgbClr val="14B8B7"/>
                 </a:solidFill>
               </a:rPr>
-              <a:t>+14% YoY</a:t>
+              <a:t>{{S03_KPI4_GROWTH}}</a:t>
             </a:r>
             <a:endParaRPr lang="en-US" sz="850" dirty="0"/>
           </a:p>
@@ -9530,7 +9530,7 @@
                 <a:ea typeface="Georgia" pitchFamily="34" charset="-122"/>
                 <a:cs typeface="Georgia" pitchFamily="34" charset="-120"/>
               </a:rPr>
-              <a:t>₹144 Cr</a:t>
+              <a:t>{{S03_KPI5_VALUE}}</a:t>
             </a:r>
             <a:endParaRPr lang="en-US" sz="1700" dirty="0"/>
           </a:p>
@@ -9566,7 +9566,7 @@
                   <a:srgbClr val="FFFFFF"/>
                 </a:solidFill>
               </a:rPr>
-              <a:t>PAT</a:t>
+              <a:t>{{S03_KPI5_LABEL}}</a:t>
             </a:r>
             <a:endParaRPr lang="en-US" sz="900" dirty="0"/>
           </a:p>
@@ -9602,7 +9602,7 @@
                   <a:srgbClr val="14B8B7"/>
                 </a:solidFill>
               </a:rPr>
-              <a:t>₹15.68 EPS</a:t>
+              <a:t>{{S03_KPI5_SUBVALUE}}</a:t>
             </a:r>
             <a:endParaRPr lang="en-US" sz="850" dirty="0"/>
           </a:p>
@@ -9663,7 +9663,7 @@
                   <a:srgbClr val="0A1628"/>
                 </a:solidFill>
               </a:rPr>
-              <a:t>AUM Growth (₹ Crore)</a:t>
+              <a:t>{{S03_CHART_TITLE}}</a:t>
             </a:r>
             <a:endParaRPr lang="en-US" sz="1100" dirty="0"/>
           </a:p>
@@ -9740,7 +9740,7 @@
                   <a:srgbClr val="0A1628"/>
                 </a:solidFill>
               </a:rPr>
-              <a:t>Key Performance Ratios</a:t>
+              <a:t>{{S03_TABLE_TITLE}}</a:t>
             </a:r>
             <a:endParaRPr lang="en-US" sz="1100" dirty="0"/>
           </a:p>
@@ -9849,7 +9849,7 @@
                             <a:srgbClr val="FFFFFF"/>
                           </a:solidFill>
                         </a:rPr>
-                        <a:t>FY24</a:t>
+                        <a:t>{{S03_PRIOR_YEAR}}</a:t>
                       </a:r>
                       <a:endParaRPr lang="en-US" sz="1000" dirty="0"/>
                     </a:p>
@@ -9910,7 +9910,7 @@
                             <a:srgbClr val="FFFFFF"/>
                           </a:solidFill>
                         </a:rPr>
-                        <a:t>FY25</a:t>
+                        <a:t>{{S03_CURRENT_YEAR}}</a:t>
                       </a:r>
                       <a:endParaRPr lang="en-US" sz="1000" dirty="0"/>
                     </a:p>
@@ -10034,7 +10034,7 @@
                             <a:srgbClr val="0A1628"/>
                           </a:solidFill>
                         </a:rPr>
-                        <a:t>19.4%</a:t>
+                        <a:t>{{S03_CRAR_PRIOR}}</a:t>
                       </a:r>
                       <a:endParaRPr lang="en-US" sz="1000" dirty="0"/>
                     </a:p>
@@ -10095,7 +10095,7 @@
                             <a:srgbClr val="0E7C7B"/>
                           </a:solidFill>
                         </a:rPr>
-                        <a:t>20.8%</a:t>
+                        <a:t>{{S03_CRAR_CURRENT}}</a:t>
                       </a:r>
                       <a:endParaRPr lang="en-US" sz="1000" dirty="0"/>
                     </a:p>
@@ -10219,7 +10219,7 @@
                             <a:srgbClr val="0A1628"/>
                           </a:solidFill>
                         </a:rPr>
-                        <a:t>2.4%</a:t>
+                        <a:t>{{S03_ROA_PRIOR}}</a:t>
                       </a:r>
                       <a:endParaRPr lang="en-US" sz="1000" dirty="0"/>
                     </a:p>
@@ -10280,7 +10280,7 @@
                             <a:srgbClr val="0E7C7B"/>
                           </a:solidFill>
                         </a:rPr>
-                        <a:t>2.8%</a:t>
+                        <a:t>{{S03_ROA_CURRENT}}</a:t>
                       </a:r>
                       <a:endParaRPr lang="en-US" sz="1000" dirty="0"/>
                     </a:p>
@@ -10404,7 +10404,7 @@
                             <a:srgbClr val="0A1628"/>
                           </a:solidFill>
                         </a:rPr>
-                        <a:t>8.7%</a:t>
+                        <a:t>{{S03_ROE_PRIOR}}</a:t>
                       </a:r>
                       <a:endParaRPr lang="en-US" sz="1000" dirty="0"/>
                     </a:p>
@@ -10465,7 +10465,7 @@
                             <a:srgbClr val="0E7C7B"/>
                           </a:solidFill>
                         </a:rPr>
-                        <a:t>9.9%</a:t>
+                        <a:t>{{S03_ROE_CURRENT}}</a:t>
                       </a:r>
                       <a:endParaRPr lang="en-US" sz="1000" dirty="0"/>
                     </a:p>
@@ -10589,7 +10589,7 @@
                             <a:srgbClr val="0A1628"/>
                           </a:solidFill>
                         </a:rPr>
-                        <a:t>2.3%</a:t>
+                        <a:t>{{S03_GNPA_PRIOR}}</a:t>
                       </a:r>
                       <a:endParaRPr lang="en-US" sz="1000" dirty="0"/>
                     </a:p>
@@ -10650,7 +10650,7 @@
                             <a:srgbClr val="0A1628"/>
                           </a:solidFill>
                         </a:rPr>
-                        <a:t>2.3%</a:t>
+                        <a:t>{{S03_GNPA_VALUE}}</a:t>
                       </a:r>
                       <a:endParaRPr lang="en-US" sz="1000" dirty="0"/>
                     </a:p>
@@ -10774,7 +10774,7 @@
                             <a:srgbClr val="0A1628"/>
                           </a:solidFill>
                         </a:rPr>
-                        <a:t>1.6%</a:t>
+                        <a:t>{{S03_NNPA_PRIOR}}</a:t>
                       </a:r>
                       <a:endParaRPr lang="en-US" sz="1000" dirty="0"/>
                     </a:p>
@@ -10835,7 +10835,7 @@
                             <a:srgbClr val="0A1628"/>
                           </a:solidFill>
                         </a:rPr>
-                        <a:t>1.6%</a:t>
+                        <a:t>{{S03_NNPA_VALUE}}</a:t>
                       </a:r>
                       <a:endParaRPr lang="en-US" sz="1000" dirty="0"/>
                     </a:p>
@@ -10959,7 +10959,7 @@
                             <a:srgbClr val="0A1628"/>
                           </a:solidFill>
                         </a:rPr>
-                        <a:t>54%</a:t>
+                        <a:t>{{S03_CTI_PRIOR}}</a:t>
                       </a:r>
                       <a:endParaRPr lang="en-US" sz="1000" dirty="0"/>
                     </a:p>
@@ -11020,7 +11020,7 @@
                             <a:srgbClr val="0A1628"/>
                           </a:solidFill>
                         </a:rPr>
-                        <a:t>54%</a:t>
+                        <a:t>{{S03_CTI_VALUE}}</a:t>
                       </a:r>
                       <a:endParaRPr lang="en-US" sz="1000" dirty="0"/>
                     </a:p>
@@ -11144,7 +11144,7 @@
                             <a:srgbClr val="0A1628"/>
                           </a:solidFill>
                         </a:rPr>
-                        <a:t>42%</a:t>
+                        <a:t>{{S03_OFFBOOK_PRIOR}}</a:t>
                       </a:r>
                       <a:endParaRPr lang="en-US" sz="1000" dirty="0"/>
                     </a:p>
@@ -11205,7 +11205,7 @@
                             <a:srgbClr val="0E7C7B"/>
                           </a:solidFill>
                         </a:rPr>
-                        <a:t>45%</a:t>
+                        <a:t>{{S03_OFFBOOK_CURRENT}}</a:t>
                       </a:r>
                       <a:endParaRPr lang="en-US" sz="1000" dirty="0"/>
                     </a:p>
@@ -11329,7 +11329,7 @@
                             <a:srgbClr val="0A1628"/>
                           </a:solidFill>
                         </a:rPr>
-                        <a:t>13.7%</a:t>
+                        <a:t>{{S03_NII_AUM_PRIOR}}</a:t>
                       </a:r>
                       <a:endParaRPr lang="en-US" sz="1000" dirty="0"/>
                     </a:p>
@@ -11390,7 +11390,7 @@
                             <a:srgbClr val="0E7C7B"/>
                           </a:solidFill>
                         </a:rPr>
-                        <a:t>14.8%</a:t>
+                        <a:t>{{S03_NII_AUM_CURRENT}}</a:t>
                       </a:r>
                       <a:endParaRPr lang="en-US" sz="1000" dirty="0"/>
                     </a:p>
@@ -11472,7 +11472,7 @@
                   <a:srgbClr val="8899AA"/>
                 </a:solidFill>
               </a:rPr>
-              <a:t>¹ Excluding equity component of CCDs</a:t>
+              <a:t>{{S03_FOOTNOTE}}</a:t>
             </a:r>
             <a:endParaRPr lang="en-US" sz="750" dirty="0"/>
           </a:p>
@@ -11568,7 +11568,7 @@
                 <a:ea typeface="Georgia" pitchFamily="34" charset="-122"/>
                 <a:cs typeface="Georgia" pitchFamily="34" charset="-120"/>
               </a:rPr>
-              <a:t>04  |  COMPETITIVE POSITIONING &amp; MOAT</a:t>
+              <a:t>{{SECTION_04_HEADER}}</a:t>
             </a:r>
             <a:endParaRPr lang="en-US" sz="1800" dirty="0"/>
           </a:p>
@@ -11626,7 +11626,7 @@
       </p:sp>
       <p:pic>
         <p:nvPicPr>
-          <p:cNvPr id="6" name="Image 0" descr="preencoded.png">    </p:cNvPr>
+          <p:cNvPr id="6" name="Image 0" descr="preencoded.png"/>
           <p:cNvPicPr>
             <a:picLocks noChangeAspect="1"/>
           </p:cNvPicPr>
@@ -11678,7 +11678,7 @@
                   <a:srgbClr val="E8C96B"/>
                 </a:solidFill>
               </a:rPr>
-              <a:t>GRO Score™ — The Competitive Edge</a:t>
+              <a:t>{{S04_LEFT_TITLE}}</a:t>
             </a:r>
             <a:endParaRPr lang="en-US" sz="1300" dirty="0"/>
           </a:p>
@@ -11747,7 +11747,7 @@
                   <a:srgbClr val="D0DCF0"/>
                 </a:solidFill>
               </a:rPr>
-              <a:t>Patented ML credit-scoring model — launched 2022, now v3.0</a:t>
+              <a:t>{{S04_BULLET1}}</a:t>
             </a:r>
             <a:endParaRPr lang="en-US" sz="1000" dirty="0"/>
           </a:p>
@@ -11765,7 +11765,7 @@
                   <a:srgbClr val="D0DCF0"/>
                 </a:solidFill>
               </a:rPr>
-              <a:t>Ingests 10,000+ data points: GST cashflows, banking transactions, bureau, psychometric &amp; alternate data</a:t>
+              <a:t>{{S04_BULLET2}}</a:t>
             </a:r>
             <a:endParaRPr lang="en-US" sz="1000" dirty="0"/>
           </a:p>
@@ -11783,7 +11783,7 @@
                   <a:srgbClr val="D0DCF0"/>
                 </a:solidFill>
               </a:rPr>
-              <a:t>1.7 lakh+ loan applications already scored — growing moat</a:t>
+              <a:t>{{S04_BULLET3}}</a:t>
             </a:r>
             <a:endParaRPr lang="en-US" sz="1000" dirty="0"/>
           </a:p>
@@ -11801,7 +11801,7 @@
                   <a:srgbClr val="D0DCF0"/>
                 </a:solidFill>
               </a:rPr>
-              <a:t>Enables loan approvals in under 48 hours — EM secured loans</a:t>
+              <a:t>{{S04_BULLET4}}</a:t>
             </a:r>
             <a:endParaRPr lang="en-US" sz="1000" dirty="0"/>
           </a:p>
@@ -11819,7 +11819,7 @@
                   <a:srgbClr val="D0DCF0"/>
                 </a:solidFill>
               </a:rPr>
-              <a:t>GNPA on EM-secured loans: 3.7–4% (well-controlled)</a:t>
+              <a:t>{{S04_BULLET5}}</a:t>
             </a:r>
             <a:endParaRPr lang="en-US" sz="1000" dirty="0"/>
           </a:p>
@@ -11837,7 +11837,7 @@
                   <a:srgbClr val="D0DCF0"/>
                 </a:solidFill>
               </a:rPr>
-              <a:t>Proprietary data flywheel: MSL transactions enrich GRO Score™</a:t>
+              <a:t>{{S04_BULLET6}}</a:t>
             </a:r>
             <a:endParaRPr lang="en-US" sz="1000" dirty="0"/>
           </a:p>
@@ -11855,7 +11855,7 @@
                   <a:srgbClr val="D0DCF0"/>
                 </a:solidFill>
               </a:rPr>
-              <a:t>No comparable patented underwriting model in MSME NBFC space</a:t>
+              <a:t>{{S04_BULLET7}}</a:t>
             </a:r>
             <a:endParaRPr lang="en-US" sz="1000" dirty="0"/>
           </a:p>
@@ -11891,7 +11891,7 @@
                   <a:srgbClr val="0A1628"/>
                 </a:solidFill>
               </a:rPr>
-              <a:t>Multi-Channel Distribution Advantage</a:t>
+              <a:t>{{S04_RIGHT_TITLE}}</a:t>
             </a:r>
             <a:endParaRPr lang="en-US" sz="1300" dirty="0"/>
           </a:p>
@@ -11924,7 +11924,7 @@
       </p:sp>
       <p:pic>
         <p:nvPicPr>
-          <p:cNvPr id="12" name="Image 1" descr="preencoded.png">    </p:cNvPr>
+          <p:cNvPr id="12" name="Image 1" descr="preencoded.png"/>
           <p:cNvPicPr>
             <a:picLocks noChangeAspect="1"/>
           </p:cNvPicPr>
@@ -11976,7 +11976,7 @@
                   <a:srgbClr val="0A1628"/>
                 </a:solidFill>
               </a:rPr>
-              <a:t>Co-Lending (44% AUM off-book)</a:t>
+              <a:t>{{S04_CARD1_TITLE}}</a:t>
             </a:r>
             <a:endParaRPr lang="en-US" sz="1100" dirty="0"/>
           </a:p>
@@ -12012,7 +12012,7 @@
                   <a:srgbClr val="1A3567"/>
                 </a:solidFill>
               </a:rPr>
-              <a:t>17 partner banks &amp; NBFCs. Capital-efficient model enabling competitive pricing for borrowers while preserving UGRO's spread.</a:t>
+              <a:t>{{S04_CARD1_BODY}}</a:t>
             </a:r>
             <a:endParaRPr lang="en-US" sz="900" dirty="0"/>
           </a:p>
@@ -12045,7 +12045,7 @@
       </p:sp>
       <p:pic>
         <p:nvPicPr>
-          <p:cNvPr id="16" name="Image 2" descr="preencoded.png">    </p:cNvPr>
+          <p:cNvPr id="16" name="Image 2" descr="preencoded.png"/>
           <p:cNvPicPr>
             <a:picLocks noChangeAspect="1"/>
           </p:cNvPicPr>
@@ -12097,7 +12097,7 @@
                   <a:srgbClr val="0A1628"/>
                 </a:solidFill>
               </a:rPr>
-              <a:t>Emerging Markets Network</a:t>
+              <a:t>{{S04_CARD2_TITLE}}</a:t>
             </a:r>
             <a:endParaRPr lang="en-US" sz="1100" dirty="0"/>
           </a:p>
@@ -12133,7 +12133,7 @@
                   <a:srgbClr val="1A3567"/>
                 </a:solidFill>
               </a:rPr>
-              <a:t>201 EM branches across Tier 2–5 towns. ~3x growth in EM disbursements YoY. Target: 400 branches, 32–35% of AUM by FY26.</a:t>
+              <a:t>{{S04_CARD2_BODY}}</a:t>
             </a:r>
             <a:endParaRPr lang="en-US" sz="900" dirty="0"/>
           </a:p>
@@ -12166,7 +12166,7 @@
       </p:sp>
       <p:pic>
         <p:nvPicPr>
-          <p:cNvPr id="20" name="Image 3" descr="preencoded.png">    </p:cNvPr>
+          <p:cNvPr id="20" name="Image 3" descr="preencoded.png"/>
           <p:cNvPicPr>
             <a:picLocks noChangeAspect="1"/>
           </p:cNvPicPr>
@@ -12218,7 +12218,7 @@
                   <a:srgbClr val="0A1628"/>
                 </a:solidFill>
               </a:rPr>
-              <a:t>MSL — Embedded Finance Engine</a:t>
+              <a:t>{{S04_CARD3_TITLE}}</a:t>
             </a:r>
             <a:endParaRPr lang="en-US" sz="1100" dirty="0"/>
           </a:p>
@@ -12254,7 +12254,7 @@
                   <a:srgbClr val="1A3567"/>
                 </a:solidFill>
               </a:rPr>
-              <a:t>Digital subsidiary with ₹743 Cr AUM. ~₹650 Cr Q4 disbursements alone. API-first, embedded in OEM/anchor ecosystems.</a:t>
+              <a:t>{{S04_CARD3_BODY}}</a:t>
             </a:r>
             <a:endParaRPr lang="en-US" sz="900" dirty="0"/>
           </a:p>
@@ -12287,7 +12287,7 @@
       </p:sp>
       <p:pic>
         <p:nvPicPr>
-          <p:cNvPr id="24" name="Image 4" descr="preencoded.png">    </p:cNvPr>
+          <p:cNvPr id="24" name="Image 4" descr="preencoded.png"/>
           <p:cNvPicPr>
             <a:picLocks noChangeAspect="1"/>
           </p:cNvPicPr>
@@ -12339,7 +12339,7 @@
                   <a:srgbClr val="0A1628"/>
                 </a:solidFill>
               </a:rPr>
-              <a:t>IND A+ Rating Upgrade</a:t>
+              <a:t>{{S04_CARD4_TITLE}}</a:t>
             </a:r>
             <a:endParaRPr lang="en-US" sz="1100" dirty="0"/>
           </a:p>
@@ -12375,7 +12375,7 @@
                   <a:srgbClr val="1A3567"/>
                 </a:solidFill>
               </a:rPr>
-              <a:t>₹1,100 Cr debentures + ₹2,600 Cr bank loans rated IND A+. Signals improving cost of funds trajectory and institutional confidence.</a:t>
+              <a:t>{{S04_CARD4_BODY}}</a:t>
             </a:r>
             <a:endParaRPr lang="en-US" sz="900" dirty="0"/>
           </a:p>
@@ -12471,7 +12471,7 @@
                 <a:ea typeface="Georgia" pitchFamily="34" charset="-122"/>
                 <a:cs typeface="Georgia" pitchFamily="34" charset="-120"/>
               </a:rPr>
-              <a:t>05  |  MARKET OPPORTUNITY</a:t>
+              <a:t>{{SECTION_05_HEADER}}</a:t>
             </a:r>
             <a:endParaRPr lang="en-US" sz="1800" dirty="0"/>
           </a:p>
@@ -12560,7 +12560,7 @@
                 <a:ea typeface="Georgia" pitchFamily="34" charset="-122"/>
                 <a:cs typeface="Georgia" pitchFamily="34" charset="-120"/>
               </a:rPr>
-              <a:t>₹103 Trillion</a:t>
+              <a:t>{{S05_HEADLINE_VALUE}}</a:t>
             </a:r>
             <a:endParaRPr lang="en-US" sz="4800" dirty="0"/>
           </a:p>
@@ -12596,7 +12596,7 @@
                   <a:srgbClr val="FFFFFF"/>
                 </a:solidFill>
               </a:rPr>
-              <a:t>India's MSME Formal Credit Gap — The Single Largest Lending Opportunity in Asia</a:t>
+              <a:t>{{S05_HEADLINE_DESC}}</a:t>
             </a:r>
             <a:endParaRPr lang="en-US" sz="1400" dirty="0"/>
           </a:p>
@@ -12660,7 +12660,7 @@
                 <a:ea typeface="Georgia" pitchFamily="34" charset="-122"/>
                 <a:cs typeface="Georgia" pitchFamily="34" charset="-120"/>
               </a:rPr>
-              <a:t>63 Million</a:t>
+              <a:t>{{S05_STAT1_VALUE}}</a:t>
             </a:r>
             <a:endParaRPr lang="en-US" sz="2600" dirty="0"/>
           </a:p>
@@ -12696,7 +12696,7 @@
                   <a:srgbClr val="0A1628"/>
                 </a:solidFill>
               </a:rPr>
-              <a:t>MSMEs in India</a:t>
+              <a:t>{{S05_STAT1_LABEL}}</a:t>
             </a:r>
             <a:endParaRPr lang="en-US" sz="1100" dirty="0"/>
           </a:p>
@@ -12732,7 +12732,7 @@
                   <a:srgbClr val="8899AA"/>
                 </a:solidFill>
               </a:rPr>
-              <a:t>Only ~25M access formal credit — 60% addressable gap</a:t>
+              <a:t>{{S05_STAT1_DESC}}</a:t>
             </a:r>
             <a:endParaRPr lang="en-US" sz="950" dirty="0"/>
           </a:p>
@@ -12796,7 +12796,7 @@
                 <a:ea typeface="Georgia" pitchFamily="34" charset="-122"/>
                 <a:cs typeface="Georgia" pitchFamily="34" charset="-120"/>
               </a:rPr>
-              <a:t>30% of GDP</a:t>
+              <a:t>{{S05_STAT2_VALUE}}</a:t>
             </a:r>
             <a:endParaRPr lang="en-US" sz="2600" dirty="0"/>
           </a:p>
@@ -12832,7 +12832,7 @@
                   <a:srgbClr val="0A1628"/>
                 </a:solidFill>
               </a:rPr>
-              <a:t>MSME Contribution</a:t>
+              <a:t>{{S05_STAT2_LABEL}}</a:t>
             </a:r>
             <a:endParaRPr lang="en-US" sz="1100" dirty="0"/>
           </a:p>
@@ -12868,7 +12868,7 @@
                   <a:srgbClr val="8899AA"/>
                 </a:solidFill>
               </a:rPr>
-              <a:t>Govt. target: raise to 50% by 2030 — massive headroom</a:t>
+              <a:t>{{S05_STAT2_DESC}}</a:t>
             </a:r>
             <a:endParaRPr lang="en-US" sz="950" dirty="0"/>
           </a:p>
@@ -12932,7 +12932,7 @@
                 <a:ea typeface="Georgia" pitchFamily="34" charset="-122"/>
                 <a:cs typeface="Georgia" pitchFamily="34" charset="-120"/>
               </a:rPr>
-              <a:t>25%</a:t>
+              <a:t>{{S05_STAT3_VALUE}}</a:t>
             </a:r>
             <a:endParaRPr lang="en-US" sz="2600" dirty="0"/>
           </a:p>
@@ -12968,7 +12968,7 @@
                   <a:srgbClr val="0A1628"/>
                 </a:solidFill>
               </a:rPr>
-              <a:t>Credit Penetration</a:t>
+              <a:t>{{S05_STAT3_LABEL}}</a:t>
             </a:r>
             <a:endParaRPr lang="en-US" sz="1100" dirty="0"/>
           </a:p>
@@ -13004,7 +13004,7 @@
                   <a:srgbClr val="8899AA"/>
                 </a:solidFill>
               </a:rPr>
-              <a:t>Lowest in Asia — digital infra set to unlock rapid growth</a:t>
+              <a:t>{{S05_STAT3_DESC}}</a:t>
             </a:r>
             <a:endParaRPr lang="en-US" sz="950" dirty="0"/>
           </a:p>
@@ -13040,7 +13040,7 @@
                   <a:srgbClr val="0A1628"/>
                 </a:solidFill>
               </a:rPr>
-              <a:t>Key Structural Tailwinds Converging Now</a:t>
+              <a:t>{{S05_TAILWINDS_TITLE}}</a:t>
             </a:r>
             <a:endParaRPr lang="en-US" sz="1200" dirty="0"/>
           </a:p>
@@ -13080,7 +13080,7 @@
                   <a:srgbClr val="1A3567"/>
                 </a:solidFill>
               </a:rPr>
-              <a:t>GST formalization: ITR filers up from 6.69 Cr (2020) to 8.9 Cr (2024) — data richness growing</a:t>
+              <a:t>{{S05_TAILWIND1}}</a:t>
             </a:r>
             <a:endParaRPr lang="en-US" sz="1000" dirty="0"/>
           </a:p>
@@ -13098,7 +13098,7 @@
                   <a:srgbClr val="1A3567"/>
                 </a:solidFill>
               </a:rPr>
-              <a:t>UPI hitting ₹24 lakh Cr monthly volumes (Mar 2025) — cashflow visibility transforming underwriting</a:t>
+              <a:t>{{S05_TAILWIND2}}</a:t>
             </a:r>
             <a:endParaRPr lang="en-US" sz="1000" dirty="0"/>
           </a:p>
@@ -13116,7 +13116,7 @@
                   <a:srgbClr val="1A3567"/>
                 </a:solidFill>
               </a:rPr>
-              <a:t>CGTMSE limit raised to ₹5 Cr; Ministry of MSME outlay ₹22,000 Cr in Union Budget 2025</a:t>
+              <a:t>{{S05_TAILWIND3}}</a:t>
             </a:r>
             <a:endParaRPr lang="en-US" sz="1000" dirty="0"/>
           </a:p>
@@ -13134,7 +13134,7 @@
                   <a:srgbClr val="1A3567"/>
                 </a:solidFill>
               </a:rPr>
-              <a:t>Account Aggregator / OCEN frameworks enabling real-time cash-flow based lending at scale</a:t>
+              <a:t>{{S05_TAILWIND4}}</a:t>
             </a:r>
             <a:endParaRPr lang="en-US" sz="1000" dirty="0"/>
           </a:p>
@@ -13230,7 +13230,7 @@
                 <a:ea typeface="Georgia" pitchFamily="34" charset="-122"/>
                 <a:cs typeface="Georgia" pitchFamily="34" charset="-120"/>
               </a:rPr>
-              <a:t>06  |  RISK FACTORS &amp; MITIGANTS</a:t>
+              <a:t>{{SECTION_06_HEADER}}</a:t>
             </a:r>
             <a:endParaRPr lang="en-US" sz="1800" dirty="0"/>
           </a:p>
@@ -13341,7 +13341,7 @@
                   <a:srgbClr val="0A1628"/>
                 </a:solidFill>
               </a:rPr>
-              <a:t>Funding &amp; Cost of Capital Risk</a:t>
+              <a:t>{{S06_RISK1_TITLE}}</a:t>
             </a:r>
             <a:endParaRPr lang="en-US" sz="1100" dirty="0"/>
           </a:p>
@@ -13377,7 +13377,7 @@
                   <a:srgbClr val="8899AA"/>
                 </a:solidFill>
               </a:rPr>
-              <a:t>NBFC borrowing costs sensitive to rating downgrades and market liquidity</a:t>
+              <a:t>{{S06_RISK1_DESC}}</a:t>
             </a:r>
             <a:endParaRPr lang="en-US" sz="900" dirty="0"/>
           </a:p>
@@ -13474,7 +13474,7 @@
                   <a:srgbClr val="1A3567"/>
                 </a:solidFill>
               </a:rPr>
-              <a:t>Mitigant: IND A+ ratings on ₹3,700 Cr+ facilities. Diversified sources: bank loans, CPs, bonds, co-lending. 17 banking partners reduce concentration.</a:t>
+              <a:t>{{S06_RISK1_MITIGANT}}</a:t>
             </a:r>
             <a:endParaRPr lang="en-US" sz="950" dirty="0"/>
           </a:p>
@@ -13560,7 +13560,7 @@
                   <a:srgbClr val="0A1628"/>
                 </a:solidFill>
               </a:rPr>
-              <a:t>Asset Quality / Credit Risk</a:t>
+              <a:t>{{S06_RISK2_TITLE}}</a:t>
             </a:r>
             <a:endParaRPr lang="en-US" sz="1100" dirty="0"/>
           </a:p>
@@ -13596,7 +13596,7 @@
                   <a:srgbClr val="8899AA"/>
                 </a:solidFill>
               </a:rPr>
-              <a:t>Rapid EM branch expansion into Tier 2–5 markets introduces higher credit risk</a:t>
+              <a:t>{{S06_RISK2_DESC}}</a:t>
             </a:r>
             <a:endParaRPr lang="en-US" sz="900" dirty="0"/>
           </a:p>
@@ -13693,7 +13693,7 @@
                   <a:srgbClr val="1A3567"/>
                 </a:solidFill>
               </a:rPr>
-              <a:t>Mitigant: GRO Score™ v3.0 underwrites every loan. GNPA at 2.3% stable YoY. EM-secured GNPA at 3.7–4%, within target credit cost bands.</a:t>
+              <a:t>{{S06_RISK2_MITIGANT}}</a:t>
             </a:r>
             <a:endParaRPr lang="en-US" sz="950" dirty="0"/>
           </a:p>
@@ -13779,7 +13779,7 @@
                   <a:srgbClr val="0A1628"/>
                 </a:solidFill>
               </a:rPr>
-              <a:t>Regulatory &amp; Compliance Risk</a:t>
+              <a:t>{{S06_RISK3_TITLE}}</a:t>
             </a:r>
             <a:endParaRPr lang="en-US" sz="1100" dirty="0"/>
           </a:p>
@@ -13815,7 +13815,7 @@
                   <a:srgbClr val="8899AA"/>
                 </a:solidFill>
               </a:rPr>
-              <a:t>RBI NBFC regulations evolving; higher risk weights on bank-to-NBFC exposures</a:t>
+              <a:t>{{S06_RISK3_DESC}}</a:t>
             </a:r>
             <a:endParaRPr lang="en-US" sz="900" dirty="0"/>
           </a:p>
@@ -13912,7 +13912,7 @@
                   <a:srgbClr val="1A3567"/>
                 </a:solidFill>
               </a:rPr>
-              <a:t>Mitigant: Strong CRAR of 20.8% (Tier 1: 18.57%). ₹1,265 Cr equity raise in FY25 provides significant headroom above regulatory minima.</a:t>
+              <a:t>{{S06_RISK3_MITIGANT}}</a:t>
             </a:r>
             <a:endParaRPr lang="en-US" sz="950" dirty="0"/>
           </a:p>
@@ -13998,7 +13998,7 @@
                   <a:srgbClr val="0A1628"/>
                 </a:solidFill>
               </a:rPr>
-              <a:t>Competitive Intensification</a:t>
+              <a:t>{{S06_RISK4_TITLE}}</a:t>
             </a:r>
             <a:endParaRPr lang="en-US" sz="1100" dirty="0"/>
           </a:p>
@@ -14034,7 +14034,7 @@
                   <a:srgbClr val="8899AA"/>
                 </a:solidFill>
               </a:rPr>
-              <a:t>Banks, fintechs and new-age NBFCs entering MSME lending segment</a:t>
+              <a:t>{{S06_RISK4_DESC}}</a:t>
             </a:r>
             <a:endParaRPr lang="en-US" sz="900" dirty="0"/>
           </a:p>
@@ -14131,7 +14131,7 @@
                   <a:srgbClr val="1A3567"/>
                 </a:solidFill>
               </a:rPr>
-              <a:t>Mitigant: Patented GRO Score™ moat, embedded finance flywheel (MSL), and 5-year head start in EM branch network create durable differentiation.</a:t>
+              <a:t>{{S06_RISK4_MITIGANT}}</a:t>
             </a:r>
             <a:endParaRPr lang="en-US" sz="950" dirty="0"/>
           </a:p>
@@ -14217,7 +14217,7 @@
                   <a:srgbClr val="0A1628"/>
                 </a:solidFill>
               </a:rPr>
-              <a:t>Execution / Scaling Risk</a:t>
+              <a:t>{{S06_RISK5_TITLE}}</a:t>
             </a:r>
             <a:endParaRPr lang="en-US" sz="1100" dirty="0"/>
           </a:p>
@@ -14253,7 +14253,7 @@
                   <a:srgbClr val="8899AA"/>
                 </a:solidFill>
               </a:rPr>
-              <a:t>Expanding to 400 EM branches and scaling MSL simultaneously is operationally intensive</a:t>
+              <a:t>{{S06_RISK5_DESC}}</a:t>
             </a:r>
             <a:endParaRPr lang="en-US" sz="900" dirty="0"/>
           </a:p>
@@ -14350,7 +14350,7 @@
                   <a:srgbClr val="1A3567"/>
                 </a:solidFill>
               </a:rPr>
-              <a:t>Mitigant: All branches on real-time digital platform with instant e-KYC. Technology-first approach with AI tools integrated into origination.</a:t>
+              <a:t>{{S06_RISK5_MITIGANT}}</a:t>
             </a:r>
             <a:endParaRPr lang="en-US" sz="950" dirty="0"/>
           </a:p>
@@ -14446,7 +14446,7 @@
                 <a:ea typeface="Georgia" pitchFamily="34" charset="-122"/>
                 <a:cs typeface="Georgia" pitchFamily="34" charset="-120"/>
               </a:rPr>
-              <a:t>07  |  FY26 STRATEGY &amp; OUTLOOK</a:t>
+              <a:t>{{SECTION_07_HEADER}}</a:t>
             </a:r>
             <a:endParaRPr lang="en-US" sz="1800" dirty="0"/>
           </a:p>
@@ -14532,7 +14532,7 @@
                   <a:srgbClr val="E8C96B"/>
                 </a:solidFill>
               </a:rPr>
-              <a:t>FY26 Targets: AUM ₹16,000–17,000 Cr  |  GNPA &lt; 2.5%  |  ROE Improvement  |  400 EM Branches</a:t>
+              <a:t>{{S07_TARGETS_BAR}}</a:t>
             </a:r>
             <a:endParaRPr lang="en-US" sz="1400" dirty="0"/>
           </a:p>
@@ -14572,7 +14572,7 @@
       </p:sp>
       <p:pic>
         <p:nvPicPr>
-          <p:cNvPr id="8" name="Image 0" descr="preencoded.png">    </p:cNvPr>
+          <p:cNvPr id="8" name="Image 0" descr="preencoded.png"/>
           <p:cNvPicPr>
             <a:picLocks noChangeAspect="1"/>
           </p:cNvPicPr>
@@ -14624,7 +14624,7 @@
                   <a:srgbClr val="0A1628"/>
                 </a:solidFill>
               </a:rPr>
-              <a:t>Deepen Emerging Market Penetration</a:t>
+              <a:t>{{S07_PILLAR1_TITLE}}</a:t>
             </a:r>
             <a:endParaRPr lang="en-US" sz="1100" dirty="0"/>
           </a:p>
@@ -14664,7 +14664,7 @@
                   <a:srgbClr val="1A3567"/>
                 </a:solidFill>
               </a:rPr>
-              <a:t>Expand EM branches from 201 → 400 by FY26</a:t>
+              <a:t>{{S07_PILLAR1_BULLET1}}</a:t>
             </a:r>
             <a:endParaRPr lang="en-US" sz="950" dirty="0"/>
           </a:p>
@@ -14682,7 +14682,7 @@
                   <a:srgbClr val="1A3567"/>
                 </a:solidFill>
               </a:rPr>
-              <a:t>Target 32–35% of AUM from EM channels</a:t>
+              <a:t>{{S07_PILLAR1_BULLET2}}</a:t>
             </a:r>
             <a:endParaRPr lang="en-US" sz="950" dirty="0"/>
           </a:p>
@@ -14700,7 +14700,7 @@
                   <a:srgbClr val="1A3567"/>
                 </a:solidFill>
               </a:rPr>
-              <a:t>Avg ticket ~₹16L, yield ~19%, disciplined credit costs</a:t>
+              <a:t>{{S07_PILLAR1_BULLET3}}</a:t>
             </a:r>
             <a:endParaRPr lang="en-US" sz="950" dirty="0"/>
           </a:p>
@@ -14740,7 +14740,7 @@
       </p:sp>
       <p:pic>
         <p:nvPicPr>
-          <p:cNvPr id="12" name="Image 1" descr="preencoded.png">    </p:cNvPr>
+          <p:cNvPr id="12" name="Image 1" descr="preencoded.png"/>
           <p:cNvPicPr>
             <a:picLocks noChangeAspect="1"/>
           </p:cNvPicPr>
@@ -14792,7 +14792,7 @@
                   <a:srgbClr val="0A1628"/>
                 </a:solidFill>
               </a:rPr>
-              <a:t>Scale Co-Lending to 50% of AUM</a:t>
+              <a:t>{{S07_PILLAR2_TITLE}}</a:t>
             </a:r>
             <a:endParaRPr lang="en-US" sz="1100" dirty="0"/>
           </a:p>
@@ -14832,7 +14832,7 @@
                   <a:srgbClr val="1A3567"/>
                 </a:solidFill>
               </a:rPr>
-              <a:t>Increase off-book AUM from 45% → 50%</a:t>
+              <a:t>{{S07_PILLAR2_BULLET1}}</a:t>
             </a:r>
             <a:endParaRPr lang="en-US" sz="950" dirty="0"/>
           </a:p>
@@ -14850,7 +14850,7 @@
                   <a:srgbClr val="1A3567"/>
                 </a:solidFill>
               </a:rPr>
-              <a:t>Add new PSU and private bank partners</a:t>
+              <a:t>{{S07_PILLAR2_BULLET2}}</a:t>
             </a:r>
             <a:endParaRPr lang="en-US" sz="950" dirty="0"/>
           </a:p>
@@ -14868,7 +14868,7 @@
                   <a:srgbClr val="1A3567"/>
                 </a:solidFill>
               </a:rPr>
-              <a:t>Priority-sector classification = cost of fund advantage</a:t>
+              <a:t>{{S07_PILLAR2_BULLET3}}</a:t>
             </a:r>
             <a:endParaRPr lang="en-US" sz="950" dirty="0"/>
           </a:p>
@@ -14908,7 +14908,7 @@
       </p:sp>
       <p:pic>
         <p:nvPicPr>
-          <p:cNvPr id="16" name="Image 2" descr="preencoded.png">    </p:cNvPr>
+          <p:cNvPr id="16" name="Image 2" descr="preencoded.png"/>
           <p:cNvPicPr>
             <a:picLocks noChangeAspect="1"/>
           </p:cNvPicPr>
@@ -14960,7 +14960,7 @@
                   <a:srgbClr val="0A1628"/>
                 </a:solidFill>
               </a:rPr>
-              <a:t>Embedded Finance &amp; MSL Acceleration</a:t>
+              <a:t>{{S07_PILLAR3_TITLE}}</a:t>
             </a:r>
             <a:endParaRPr lang="en-US" sz="1100" dirty="0"/>
           </a:p>
@@ -15000,7 +15000,7 @@
                   <a:srgbClr val="1A3567"/>
                 </a:solidFill>
               </a:rPr>
-              <a:t>MSL AUM run-rate targeting rapid scale-up</a:t>
+              <a:t>{{S07_PILLAR3_BULLET1}}</a:t>
             </a:r>
             <a:endParaRPr lang="en-US" sz="950" dirty="0"/>
           </a:p>
@@ -15018,7 +15018,7 @@
                   <a:srgbClr val="1A3567"/>
                 </a:solidFill>
               </a:rPr>
-              <a:t>Retailer finance via OEM/anchor ecosystem APIs</a:t>
+              <a:t>{{S07_PILLAR3_BULLET2}}</a:t>
             </a:r>
             <a:endParaRPr lang="en-US" sz="950" dirty="0"/>
           </a:p>
@@ -15036,7 +15036,7 @@
                   <a:srgbClr val="1A3567"/>
                 </a:solidFill>
               </a:rPr>
-              <a:t>Micro-insurance and financial services bundling</a:t>
+              <a:t>{{S07_PILLAR3_BULLET3}}</a:t>
             </a:r>
             <a:endParaRPr lang="en-US" sz="950" dirty="0"/>
           </a:p>
@@ -15076,7 +15076,7 @@
       </p:sp>
       <p:pic>
         <p:nvPicPr>
-          <p:cNvPr id="20" name="Image 3" descr="preencoded.png">    </p:cNvPr>
+          <p:cNvPr id="20" name="Image 3" descr="preencoded.png"/>
           <p:cNvPicPr>
             <a:picLocks noChangeAspect="1"/>
           </p:cNvPicPr>
@@ -15128,7 +15128,7 @@
                   <a:srgbClr val="0A1628"/>
                 </a:solidFill>
               </a:rPr>
-              <a:t>Profitability &amp; Operating Leverage</a:t>
+              <a:t>{{S07_PILLAR4_TITLE}}</a:t>
             </a:r>
             <a:endParaRPr lang="en-US" sz="1100" dirty="0"/>
           </a:p>
@@ -15168,7 +15168,7 @@
                   <a:srgbClr val="1A3567"/>
                 </a:solidFill>
               </a:rPr>
-              <a:t>Higher-yield product mix improvement</a:t>
+              <a:t>{{S07_PILLAR4_BULLET1}}</a:t>
             </a:r>
             <a:endParaRPr lang="en-US" sz="950" dirty="0"/>
           </a:p>
@@ -15186,7 +15186,7 @@
                   <a:srgbClr val="1A3567"/>
                 </a:solidFill>
               </a:rPr>
-              <a:t>Cost-to-income ratio reduction via tech-led efficiency</a:t>
+              <a:t>{{S07_PILLAR4_BULLET2}}</a:t>
             </a:r>
             <a:endParaRPr lang="en-US" sz="950" dirty="0"/>
           </a:p>
@@ -15204,7 +15204,7 @@
                   <a:srgbClr val="1A3567"/>
                 </a:solidFill>
               </a:rPr>
-              <a:t>Debt rating trajectory → further cost-of-funds compression</a:t>
+              <a:t>{{S07_PILLAR4_BULLET3}}</a:t>
             </a:r>
             <a:endParaRPr lang="en-US" sz="950" dirty="0"/>
           </a:p>

</xml_diff>